<commit_message>
State the optional line-up check accurately and drop two unused imports
The report and the "How it works" slide said no line-up is used. The app has an optional,
reviewer-connected line-up check that no reported number uses. The report now describes it
with the test result and its caveats, the slides say a line-up is optional, and the
scalability slide gives the 53.0% to 64.2% test with true squads. Removes the Form and Path
imports that the upload removal left unused in app.py.

Co-Authored-By: Claude Sonnet 5.5 <noreply@anthropic.com>
</commit_message>
<xml_diff>
--- a/Documentation/PitchProfile_Presentation.pptx
+++ b/Documentation/PitchProfile_Presentation.pptx
@@ -140,7 +140,7 @@
   <p:extLst>
     <p:ext uri="{521415D9-36F7-43E2-AB2F-B90AF26B5E84}">
       <p14:sectionLst xmlns:p14="http://schemas.microsoft.com/office/powerpoint/2010/main">
-        <p14:section name="1 · Open problem" id="{f4925d56-c70c-79d8-656c-a4113e59f05f}">
+        <p14:section name="1 · Open problem" id="{01423f6c-552b-c53c-1dfb-ad9a46b13c7a}">
           <p14:sldIdLst>
             <p14:sldId id="256"/>
             <p14:sldId id="257"/>
@@ -148,12 +148,12 @@
             <p14:sldId id="259"/>
           </p14:sldIdLst>
         </p14:section>
-        <p14:section name="2 · Phases" id="{49de8c2b-3ef5-cbab-1760-73a2fc740720}">
+        <p14:section name="2 · Phases" id="{c8e4973d-e4c3-435e-2262-b1e4f1f69988}">
           <p14:sldIdLst>
             <p14:sldId id="260"/>
           </p14:sldIdLst>
         </p14:section>
-        <p14:section name="3 · Problems and models" id="{fd473989-a523-6e48-43b0-206dc2243054}">
+        <p14:section name="3 · Problems and models" id="{4c40f2cb-98d1-367b-1c37-5f87531fab9f}">
           <p14:sldIdLst>
             <p14:sldId id="261"/>
             <p14:sldId id="262"/>
@@ -170,13 +170,13 @@
             <p14:sldId id="273"/>
           </p14:sldIdLst>
         </p14:section>
-        <p14:section name="4 · Results and scalability" id="{adefd6ef-4dd4-50d8-1a27-5cd31ac465d1}">
+        <p14:section name="4 · Results and scalability" id="{d6cc7bb4-9919-7442-2f7e-3f849cecf9c4}">
           <p14:sldIdLst>
             <p14:sldId id="274"/>
             <p14:sldId id="275"/>
           </p14:sldIdLst>
         </p14:section>
-        <p14:section name="Backup" id="{5a07d7dd-80f2-4967-d1b7-46b65613f354}">
+        <p14:section name="Backup" id="{d273c363-248e-f671-e1d0-8f1da7b9ee67}">
           <p14:sldIdLst>
             <p14:sldId id="276"/>
             <p14:sldId id="277"/>
@@ -192,7 +192,7 @@
             <p14:sldId id="287"/>
           </p14:sldIdLst>
         </p14:section>
-        <p14:section name="Appendix" id="{dd137b36-4a3a-7c89-eeaa-6da2fe052199}">
+        <p14:section name="Appendix" id="{1d453743-208a-e5b8-614d-15fc8d49c485}">
           <p14:sldIdLst>
             <p14:sldId id="288"/>
             <p14:sldId id="289"/>
@@ -4373,7 +4373,7 @@
           <a:p>
             <a:r>
               <a:rPr lang="en-US" dirty="0"/>
-              <a:t>About 60 seconds. To close, where this goes. Top left, scaling to more matches: each match is processed on its own, in about three quarters of its length on one RTX 3090, so a 90-minute match takes about 70 minutes, and only broadcast video is needed. Top right, better models: moving the identity model from 19 to 48 training games raised the share of player time given the right name from 48.9% to 53.0%, while the ball is still the weakest link, found in under half of the frames where it is visible. Bottom left, naming more players: about half of visible player time is still unnamed, and line-ups, more thumbnails and the naming panel help, while unnamed players keep their statistics. Bottom right, a possible extension: grading players against playing styles. Nobody has graded players yet, so there are no results; a future version needs labelled players first, and our player statistics would be its input.</a:t>
+              <a:t>About 60 seconds. To close, where this goes. Top left, scaling to more matches: each match is processed on its own, in about three quarters of its length on one RTX 3090, so a 90-minute match takes about 70 minutes, and only broadcast video is needed. Top right, better models: moving the identity model from 19 to 48 training games raised the share of player time given the right name from 48.9% to 53.0%, while the ball is still the weakest link, found in under half of the frames where it is visible. Bottom left, naming more players: about half of visible player time is still unnamed, and a line-up helped in a test with the true squads, raising the right-name share from 53.0% to 64.2%, while more thumbnails and the naming panel also help and unnamed players keep their statistics. Bottom right, a possible extension: grading players against playing styles. Nobody has graded players yet, so there are no results; a future version needs labelled players first, and our player statistics would be its input.</a:t>
             </a:r>
             <a:endParaRPr lang="en-US" dirty="0"/>
           </a:p>
@@ -19203,7 +19203,7 @@
                   <a:schemeClr val="bg2"/>
                 </a:solidFill>
               </a:rPr>
-              <a:t>About half of visible player time is still unnamed. Line-ups, more thumbnails and the naming panel give names, and unnamed players keep their statistics.</a:t>
+              <a:t>About half of visible player time is still unnamed. In a test with the true squads, a line-up raised the right-name share from 53.0% to 64.2%; more thumbnails and the naming panel also give names, and unnamed players keep their statistics.</a:t>
             </a:r>
             <a:endParaRPr lang="en-US" sz="1800" dirty="0"/>
           </a:p>
@@ -20929,7 +20929,7 @@
                   <a:schemeClr val="tx2"/>
                 </a:solidFill>
               </a:rPr>
-              <a:t>No data feeds, no line-ups.</a:t>
+              <a:t>No data feeds. A line-up is optional and not used for any number shown.</a:t>
             </a:r>
             <a:endParaRPr lang="en-US" sz="2200" dirty="0"/>
           </a:p>

</xml_diff>